<commit_message>
Refactor Hungarian language strings for consistency and clarity across multiple JavaScript files; update password hashing script comments; modify database files; remove unnecessary SQLite WAL and SHM files.
</commit_message>
<xml_diff>
--- a/Tanfolyamok_prezentacio.pptx
+++ b/Tanfolyamok_prezentacio.pptx
@@ -3185,7 +3185,7 @@
                 </a:solidFill>
                 <a:latin typeface="Segoe UI"/>
               </a:rPr>
-              <a:t>Tanfolyam-kezelo webalkalmazas</a:t>
+              <a:t>Tanfolyam-kezelő webalkalmazás</a:t>
             </a:r>
           </a:p>
         </p:txBody>
@@ -3220,7 +3220,7 @@
                 </a:solidFill>
                 <a:latin typeface="Segoe UI"/>
               </a:rPr>
-              <a:t>Pogany Frigyes Technikum  |  Budapest, 2026</a:t>
+              <a:t>Pogány Frigyes Technikum  |  Budapest, 2026</a:t>
             </a:r>
           </a:p>
         </p:txBody>
@@ -3255,7 +3255,7 @@
                 </a:solidFill>
                 <a:latin typeface="Segoe UI"/>
               </a:rPr>
-              <a:t>Andorfer Vendel  |  Babai Mate  |  Varga Matyas</a:t>
+              <a:t>Andorfer Vendel  |  Babai Máté  |  Varga Mátyás</a:t>
             </a:r>
           </a:p>
         </p:txBody>
@@ -3316,7 +3316,7 @@
                 </a:solidFill>
                 <a:latin typeface="Segoe UI"/>
               </a:rPr>
-              <a:t>Tanfolyamok - Pogany Frigyes Technikum</a:t>
+              <a:t>Tanfolyamok - Pogány Frigyes Technikum</a:t>
             </a:r>
           </a:p>
         </p:txBody>
@@ -3386,7 +3386,7 @@
                 </a:solidFill>
                 <a:latin typeface="Segoe UI"/>
               </a:rPr>
-              <a:t>4. Hogyan tarolja az adatokat?</a:t>
+              <a:t>4. Hogyan tárolja az adatokat?</a:t>
             </a:r>
           </a:p>
         </p:txBody>
@@ -3439,7 +3439,7 @@
                 </a:solidFill>
                 <a:latin typeface="Segoe UI"/>
               </a:rPr>
-              <a:t>Tanfolyamok - Pogany Frigyes Technikum</a:t>
+              <a:t>Tanfolyamok - Pogány Frigyes Technikum</a:t>
             </a:r>
           </a:p>
         </p:txBody>
@@ -3509,7 +3509,7 @@
                 </a:solidFill>
                 <a:latin typeface="Segoe UI"/>
               </a:rPr>
-              <a:t>Harom tablazat az adatbazisban</a:t>
+              <a:t>Három táblázat az adatbázisban</a:t>
             </a:r>
           </a:p>
         </p:txBody>
@@ -3545,7 +3545,7 @@
                 <a:latin typeface="Segoe UI"/>
               </a:rPr>
               <a:t>kepzesek
-(tanfolyam tipusok)</a:t>
+(tanfolyam típusok)</a:t>
             </a:r>
           </a:p>
           <a:p>
@@ -3569,7 +3569,7 @@
                 </a:solidFill>
                 <a:latin typeface="Segoe UI"/>
               </a:rPr>
-              <a:t>kid - sorszam</a:t>
+              <a:t>kid - sorszám</a:t>
             </a:r>
           </a:p>
           <a:p>
@@ -3581,7 +3581,7 @@
                 </a:solidFill>
                 <a:latin typeface="Segoe UI"/>
               </a:rPr>
-              <a:t>knev - nev</a:t>
+              <a:t>knév - név</a:t>
             </a:r>
           </a:p>
           <a:p>
@@ -3593,7 +3593,7 @@
                 </a:solidFill>
                 <a:latin typeface="Segoe UI"/>
               </a:rPr>
-              <a:t>oraszam - hany oras</a:t>
+              <a:t>óraszám - hány órás</a:t>
             </a:r>
           </a:p>
         </p:txBody>
@@ -3653,7 +3653,7 @@
                 </a:solidFill>
                 <a:latin typeface="Segoe UI"/>
               </a:rPr>
-              <a:t>csid - sorszam</a:t>
+              <a:t>csid - sorszám</a:t>
             </a:r>
           </a:p>
           <a:p>
@@ -3665,7 +3665,7 @@
                 </a:solidFill>
                 <a:latin typeface="Segoe UI"/>
               </a:rPr>
-              <a:t>kid - melyik kepzes</a:t>
+              <a:t>kid - melyik képzés</a:t>
             </a:r>
           </a:p>
           <a:p>
@@ -3677,7 +3677,7 @@
                 </a:solidFill>
                 <a:latin typeface="Segoe UI"/>
               </a:rPr>
-              <a:t>indulas - datum</a:t>
+              <a:t>indulás - dátum</a:t>
             </a:r>
           </a:p>
           <a:p>
@@ -3749,7 +3749,7 @@
                 </a:solidFill>
                 <a:latin typeface="Segoe UI"/>
               </a:rPr>
-              <a:t>jid - sorszam</a:t>
+              <a:t>jid - sorszám</a:t>
             </a:r>
           </a:p>
           <a:p>
@@ -3773,7 +3773,7 @@
                 </a:solidFill>
                 <a:latin typeface="Segoe UI"/>
               </a:rPr>
-              <a:t>nev, szul.nev, szul.ido</a:t>
+              <a:t>név, szül.név, szül.idő</a:t>
             </a:r>
           </a:p>
           <a:p>
@@ -3832,7 +3832,7 @@
                 </a:solidFill>
                 <a:latin typeface="Segoe UI"/>
               </a:rPr>
-              <a:t>Kapcsolatok: Egy kepzeshez tobb csoport tartozhat, egy csoporthoz tobb jelentkezo.</a:t>
+              <a:t>Kapcsolatok: Egy képzéshez több csoport tartozhat, egy csoporthoz több jelentkező.</a:t>
             </a:r>
           </a:p>
           <a:p>
@@ -3844,7 +3844,7 @@
                 </a:solidFill>
                 <a:latin typeface="Segoe UI"/>
               </a:rPr>
-              <a:t>Fontos: egy csoportba maximum 8 fo jelentkezhet.</a:t>
+              <a:t>Fontos: egy csoportba maximum 8 fő jelentkezhet.</a:t>
             </a:r>
           </a:p>
         </p:txBody>
@@ -3905,7 +3905,7 @@
                 </a:solidFill>
                 <a:latin typeface="Segoe UI"/>
               </a:rPr>
-              <a:t>Tanfolyamok - Pogany Frigyes Technikum</a:t>
+              <a:t>Tanfolyamok - Pogány Frigyes Technikum</a:t>
             </a:r>
           </a:p>
         </p:txBody>
@@ -3975,7 +3975,7 @@
                 </a:solidFill>
                 <a:latin typeface="Segoe UI"/>
               </a:rPr>
-              <a:t>5. Mit lat a latogato?</a:t>
+              <a:t>5. Mit lát a látogató?</a:t>
             </a:r>
           </a:p>
         </p:txBody>
@@ -4028,7 +4028,7 @@
                 </a:solidFill>
                 <a:latin typeface="Segoe UI"/>
               </a:rPr>
-              <a:t>Tanfolyamok - Pogany Frigyes Technikum</a:t>
+              <a:t>Tanfolyamok - Pogány Frigyes Technikum</a:t>
             </a:r>
           </a:p>
         </p:txBody>
@@ -4098,7 +4098,7 @@
                 </a:solidFill>
                 <a:latin typeface="Segoe UI"/>
               </a:rPr>
-              <a:t>A fooldal felulrol lefele</a:t>
+              <a:t>A főoldal felülről lefele</a:t>
             </a:r>
           </a:p>
         </p:txBody>
@@ -4133,7 +4133,7 @@
                 </a:solidFill>
                 <a:latin typeface="Segoe UI"/>
               </a:rPr>
-              <a:t>Fejlec + menu</a:t>
+              <a:t>Fejléc + menü</a:t>
             </a:r>
           </a:p>
           <a:p>
@@ -4145,7 +4145,7 @@
                 </a:solidFill>
                 <a:latin typeface="Segoe UI"/>
               </a:rPr>
-              <a:t>   Iskola neve, navigacios linkek</a:t>
+              <a:t>   Iskola neve, navigációs linkek</a:t>
             </a:r>
           </a:p>
           <a:p>
@@ -4169,7 +4169,7 @@
                 </a:solidFill>
                 <a:latin typeface="Segoe UI"/>
               </a:rPr>
-              <a:t>3 tanfolyam kartya</a:t>
+              <a:t>3 tanfolyam kártya</a:t>
             </a:r>
           </a:p>
           <a:p>
@@ -4181,7 +4181,7 @@
                 </a:solidFill>
                 <a:latin typeface="Segoe UI"/>
               </a:rPr>
-              <a:t>   Kep, leiras, "Reszletek" link</a:t>
+              <a:t>   Kép, leírás, "Részletek" link</a:t>
             </a:r>
           </a:p>
           <a:p>
@@ -4205,7 +4205,7 @@
                 </a:solidFill>
                 <a:latin typeface="Segoe UI"/>
               </a:rPr>
-              <a:t>Indulo csoportok tabla</a:t>
+              <a:t>Induló csoportok tábla</a:t>
             </a:r>
           </a:p>
           <a:p>
@@ -4217,7 +4217,7 @@
                 </a:solidFill>
                 <a:latin typeface="Segoe UI"/>
               </a:rPr>
-              <a:t>   Automatikusan frissul: melyik kepzes mikor, hol, mennyi a szabad hely</a:t>
+              <a:t>   Automatikusan frissül: melyik képzés mikor, hol, mennyi a szabad hely</a:t>
             </a:r>
           </a:p>
           <a:p>
@@ -4241,7 +4241,7 @@
                 </a:solidFill>
                 <a:latin typeface="Segoe UI"/>
               </a:rPr>
-              <a:t>Jelentkezesi urlap</a:t>
+              <a:t>Jelentkezési űrlap</a:t>
             </a:r>
           </a:p>
           <a:p>
@@ -4253,7 +4253,7 @@
                 </a:solidFill>
                 <a:latin typeface="Segoe UI"/>
               </a:rPr>
-              <a:t>   Adatok kitoltese + "Jelentkezem" gomb</a:t>
+              <a:t>   Adatok kitöltése + "Jelentkezem" gomb</a:t>
             </a:r>
           </a:p>
           <a:p>
@@ -4277,7 +4277,7 @@
                 </a:solidFill>
                 <a:latin typeface="Segoe UI"/>
               </a:rPr>
-              <a:t>Admin belepes</a:t>
+              <a:t>Admin belépés</a:t>
             </a:r>
           </a:p>
           <a:p>
@@ -4289,7 +4289,7 @@
                 </a:solidFill>
                 <a:latin typeface="Segoe UI"/>
               </a:rPr>
-              <a:t>   Jelszo mezo + gomb (az oldal aljan)</a:t>
+              <a:t>   Jelszó mező + gomb (az oldal alján)</a:t>
             </a:r>
           </a:p>
           <a:p>
@@ -4354,7 +4354,7 @@
                 </a:solidFill>
                 <a:latin typeface="Segoe UI"/>
               </a:rPr>
-              <a:t>Tanfolyamok - Pogany Frigyes Technikum</a:t>
+              <a:t>Tanfolyamok - Pogány Frigyes Technikum</a:t>
             </a:r>
           </a:p>
         </p:txBody>
@@ -4424,7 +4424,7 @@
                 </a:solidFill>
                 <a:latin typeface="Segoe UI"/>
               </a:rPr>
-              <a:t>Jelentkezesi folyamat</a:t>
+              <a:t>Jelentkezési folyamat</a:t>
             </a:r>
           </a:p>
         </p:txBody>
@@ -4459,7 +4459,7 @@
                 </a:solidFill>
                 <a:latin typeface="Segoe UI"/>
               </a:rPr>
-              <a:t>1. A latogato kitolti az urlapot</a:t>
+              <a:t>1. A látogató kitölti az űrlapot</a:t>
             </a:r>
           </a:p>
           <a:p>
@@ -4483,7 +4483,7 @@
                 </a:solidFill>
                 <a:latin typeface="Segoe UI"/>
               </a:rPr>
-              <a:t>3. A bongeszo ellenorzi az adatokat (kor, hosszak, pipa)</a:t>
+              <a:t>3. A böngésző ellenőrzi az adatokat (kor, hosszak, pipa)</a:t>
             </a:r>
           </a:p>
           <a:p>
@@ -4495,7 +4495,7 @@
                 </a:solidFill>
                 <a:latin typeface="Segoe UI"/>
               </a:rPr>
-              <a:t>4. Ha rendben van, elkuldi a szervernek</a:t>
+              <a:t>4. Ha rendben van, elküldi a szervernek</a:t>
             </a:r>
           </a:p>
           <a:p>
@@ -4507,7 +4507,7 @@
                 </a:solidFill>
                 <a:latin typeface="Segoe UI"/>
               </a:rPr>
-              <a:t>5. A szerver is ellenoriz: letezik a csoport? van hely? uj e-mail?</a:t>
+              <a:t>5. A szerver is ellenőriz: létezik a csoport? van hely? új e-mail?</a:t>
             </a:r>
           </a:p>
           <a:p>
@@ -4519,7 +4519,7 @@
                 </a:solidFill>
                 <a:latin typeface="Segoe UI"/>
               </a:rPr>
-              <a:t>6. Ha minden stimmel: a jelentkezest elmenti</a:t>
+              <a:t>6. Ha minden stimmel: a jelentkezést elmenti</a:t>
             </a:r>
           </a:p>
           <a:p>
@@ -4531,7 +4531,7 @@
                 </a:solidFill>
                 <a:latin typeface="Segoe UI"/>
               </a:rPr>
-              <a:t>7. A felhasznalo "Sikeres jelentkezes!" uzenetet kap</a:t>
+              <a:t>7. A felhasznalo "Sikeres jelentkezes!" üzenetet kap</a:t>
             </a:r>
           </a:p>
           <a:p>
@@ -4555,7 +4555,7 @@
                 </a:solidFill>
                 <a:latin typeface="Segoe UI"/>
               </a:rPr>
-              <a:t>Ha valami nem stimmel, a felhasznalo hibaUzenetet kap (pl. "A csoport megtelt").</a:t>
+              <a:t>Ha valami nem stimmel, a felhasználó hibaüzenetet kap (pl. "A csoport megtelt").</a:t>
             </a:r>
           </a:p>
         </p:txBody>
@@ -4616,7 +4616,7 @@
                 </a:solidFill>
                 <a:latin typeface="Segoe UI"/>
               </a:rPr>
-              <a:t>Tanfolyamok - Pogany Frigyes Technikum</a:t>
+              <a:t>Tanfolyamok - Pogány Frigyes Technikum</a:t>
             </a:r>
           </a:p>
         </p:txBody>
@@ -4686,7 +4686,7 @@
                 </a:solidFill>
                 <a:latin typeface="Segoe UI"/>
               </a:rPr>
-              <a:t>6. Mit lat az admin?</a:t>
+              <a:t>6. Mit lát az admin?</a:t>
             </a:r>
           </a:p>
         </p:txBody>
@@ -4739,7 +4739,7 @@
                 </a:solidFill>
                 <a:latin typeface="Segoe UI"/>
               </a:rPr>
-              <a:t>Tanfolyamok - Pogany Frigyes Technikum</a:t>
+              <a:t>Tanfolyamok - Pogány Frigyes Technikum</a:t>
             </a:r>
           </a:p>
         </p:txBody>
@@ -4809,7 +4809,7 @@
                 </a:solidFill>
                 <a:latin typeface="Segoe UI"/>
               </a:rPr>
-              <a:t>Az admin felulet oldalai</a:t>
+              <a:t>Az admin felület oldalai</a:t>
             </a:r>
           </a:p>
         </p:txBody>
@@ -4856,7 +4856,7 @@
                 </a:solidFill>
                 <a:latin typeface="Segoe UI"/>
               </a:rPr>
-              <a:t>A fooldal aljan megadja a jelszot</a:t>
+              <a:t>A főoldal alján megadja a jelszót</a:t>
             </a:r>
           </a:p>
           <a:p>
@@ -4868,7 +4868,7 @@
                 </a:solidFill>
                 <a:latin typeface="Segoe UI"/>
               </a:rPr>
-              <a:t>Ha helyes: 1 oras "igazolvanyt" kap</a:t>
+              <a:t>Ha helyes: 1 órás "igazolvanyt" kap</a:t>
             </a:r>
           </a:p>
           <a:p>
@@ -4880,7 +4880,7 @@
                 </a:solidFill>
                 <a:latin typeface="Segoe UI"/>
               </a:rPr>
-              <a:t>Atiranyitja a csoportok oldalra</a:t>
+              <a:t>Átirányítja a csoportok oldalra</a:t>
             </a:r>
           </a:p>
           <a:p>
@@ -4916,7 +4916,7 @@
                 </a:solidFill>
                 <a:latin typeface="Segoe UI"/>
               </a:rPr>
-              <a:t>Az igazolvany torlesre kerul</a:t>
+              <a:t>Az igazolvány törlésre kerül</a:t>
             </a:r>
           </a:p>
           <a:p>
@@ -4928,7 +4928,7 @@
                 </a:solidFill>
                 <a:latin typeface="Segoe UI"/>
               </a:rPr>
-              <a:t>Visszakerul a fooldra</a:t>
+              <a:t>Visszakerül a főoldalra</a:t>
             </a:r>
           </a:p>
         </p:txBody>
@@ -4963,7 +4963,7 @@
                 </a:solidFill>
                 <a:latin typeface="Segoe UI"/>
               </a:rPr>
-              <a:t>Elerheto oldalak:</a:t>
+              <a:t>Elérhető oldalak:</a:t>
             </a:r>
           </a:p>
           <a:p>
@@ -4999,7 +4999,7 @@
                 </a:solidFill>
                 <a:latin typeface="Segoe UI"/>
               </a:rPr>
-              <a:t>  Osszes csoport listaja + uj felvetele</a:t>
+              <a:t>  Összes csoport listája + új felvétele</a:t>
             </a:r>
           </a:p>
           <a:p>
@@ -5023,7 +5023,7 @@
                 </a:solidFill>
                 <a:latin typeface="Segoe UI"/>
               </a:rPr>
-              <a:t>  Egy csoport jelentkezoi + uj felvetele</a:t>
+              <a:t>  Egy csoport jelentkezői + új felvétele</a:t>
             </a:r>
           </a:p>
           <a:p>
@@ -5035,7 +5035,7 @@
                 </a:solidFill>
                 <a:latin typeface="Segoe UI"/>
               </a:rPr>
-              <a:t>Csoport modositas</a:t>
+              <a:t>Csoport módosítás</a:t>
             </a:r>
           </a:p>
           <a:p>
@@ -5047,7 +5047,7 @@
                 </a:solidFill>
                 <a:latin typeface="Segoe UI"/>
               </a:rPr>
-              <a:t>  Meglevo csoport adatainak szerkesztese</a:t>
+              <a:t>  Meglévő csoport adatainak szerkesztése</a:t>
             </a:r>
           </a:p>
           <a:p>
@@ -5059,7 +5059,7 @@
                 </a:solidFill>
                 <a:latin typeface="Segoe UI"/>
               </a:rPr>
-              <a:t>Jelentkezo modositas</a:t>
+              <a:t>Jelentkező módosítás</a:t>
             </a:r>
           </a:p>
           <a:p>
@@ -5071,7 +5071,7 @@
                 </a:solidFill>
                 <a:latin typeface="Segoe UI"/>
               </a:rPr>
-              <a:t>  Egy szemely adatainak szerkesztese</a:t>
+              <a:t>  Egy személy adatainak szerkesztése</a:t>
             </a:r>
           </a:p>
           <a:p>
@@ -5083,7 +5083,7 @@
                 </a:solidFill>
                 <a:latin typeface="Segoe UI"/>
               </a:rPr>
-              <a:t>Admin sugo</a:t>
+              <a:t>Admin súgó</a:t>
             </a:r>
           </a:p>
           <a:p>
@@ -5095,7 +5095,7 @@
                 </a:solidFill>
                 <a:latin typeface="Segoe UI"/>
               </a:rPr>
-              <a:t>  Hasznalati utmutato</a:t>
+              <a:t>  Használati útmutató</a:t>
             </a:r>
           </a:p>
         </p:txBody>
@@ -5156,7 +5156,7 @@
                 </a:solidFill>
                 <a:latin typeface="Segoe UI"/>
               </a:rPr>
-              <a:t>Tanfolyamok - Pogany Frigyes Technikum</a:t>
+              <a:t>Tanfolyamok - Pogány Frigyes Technikum</a:t>
             </a:r>
           </a:p>
         </p:txBody>
@@ -5226,7 +5226,7 @@
                 </a:solidFill>
                 <a:latin typeface="Segoe UI"/>
               </a:rPr>
-              <a:t>7. Hogyan kommunikal a felulet a szerverrel?</a:t>
+              <a:t>7. Hogyan kommunikál a felület a szerverrel?</a:t>
             </a:r>
           </a:p>
         </p:txBody>
@@ -5279,7 +5279,7 @@
                 </a:solidFill>
                 <a:latin typeface="Segoe UI"/>
               </a:rPr>
-              <a:t>Tanfolyamok - Pogany Frigyes Technikum</a:t>
+              <a:t>Tanfolyamok - Pogány Frigyes Technikum</a:t>
             </a:r>
           </a:p>
         </p:txBody>
@@ -5349,7 +5349,7 @@
                 </a:solidFill>
                 <a:latin typeface="Segoe UI"/>
               </a:rPr>
-              <a:t>Vegpontok: a szerver "ajtoi"</a:t>
+              <a:t>Végpontok: a szerver "ajtoi"</a:t>
             </a:r>
           </a:p>
         </p:txBody>
@@ -5384,7 +5384,7 @@
                 </a:solidFill>
                 <a:latin typeface="Segoe UI"/>
               </a:rPr>
-              <a:t>Nyilvanos (barki eleri):</a:t>
+              <a:t>Nyilvános (bárki eléri):</a:t>
             </a:r>
           </a:p>
           <a:p>
@@ -5408,7 +5408,7 @@
                 </a:solidFill>
                 <a:latin typeface="Segoe UI"/>
               </a:rPr>
-              <a:t>Csoportok listaja</a:t>
+              <a:t>Csoportok listája</a:t>
             </a:r>
           </a:p>
           <a:p>
@@ -5420,7 +5420,7 @@
                 </a:solidFill>
                 <a:latin typeface="Segoe UI"/>
               </a:rPr>
-              <a:t>  A meg el nem indult csoportokat adja vissza</a:t>
+              <a:t>  A még el nem indult csoportokat adja vissza</a:t>
             </a:r>
           </a:p>
           <a:p>
@@ -5456,7 +5456,7 @@
                 </a:solidFill>
                 <a:latin typeface="Segoe UI"/>
               </a:rPr>
-              <a:t>  A jelentkezo adatait rogziti</a:t>
+              <a:t>  A jelentkező adatait rögzíti</a:t>
             </a:r>
           </a:p>
           <a:p>
@@ -5468,7 +5468,7 @@
                 </a:solidFill>
                 <a:latin typeface="Segoe UI"/>
               </a:rPr>
-              <a:t>  Ellenorzi: van hely? uj e-mail? letezik a csoport?</a:t>
+              <a:t>  Ellenőrzi: van hely? új e-mail? létezik a csoport?</a:t>
             </a:r>
           </a:p>
         </p:txBody>
@@ -5503,7 +5503,7 @@
                 </a:solidFill>
                 <a:latin typeface="Segoe UI"/>
               </a:rPr>
-              <a:t>Admin (csak belepve):</a:t>
+              <a:t>Admin (csak belépve):</a:t>
             </a:r>
           </a:p>
           <a:p>
@@ -5527,7 +5527,7 @@
                 </a:solidFill>
                 <a:latin typeface="Segoe UI"/>
               </a:rPr>
-              <a:t>Bejelentkezes (jelszo ellen. + token)</a:t>
+              <a:t>Bejelentkezés (jelszó ellen. + token)</a:t>
             </a:r>
           </a:p>
           <a:p>
@@ -5539,7 +5539,7 @@
                 </a:solidFill>
                 <a:latin typeface="Segoe UI"/>
               </a:rPr>
-              <a:t>Osszes csoport listaja</a:t>
+              <a:t>Összes csoport listája</a:t>
             </a:r>
           </a:p>
           <a:p>
@@ -5551,7 +5551,7 @@
                 </a:solidFill>
                 <a:latin typeface="Segoe UI"/>
               </a:rPr>
-              <a:t>Uj csoport hozzaadasa</a:t>
+              <a:t>Új csoport hozzáadása</a:t>
             </a:r>
           </a:p>
           <a:p>
@@ -5563,7 +5563,7 @@
                 </a:solidFill>
                 <a:latin typeface="Segoe UI"/>
               </a:rPr>
-              <a:t>Csoport adatainak lekerese</a:t>
+              <a:t>Csoport adatainak lekérése</a:t>
             </a:r>
           </a:p>
           <a:p>
@@ -5575,7 +5575,7 @@
                 </a:solidFill>
                 <a:latin typeface="Segoe UI"/>
               </a:rPr>
-              <a:t>Csoport modositasa</a:t>
+              <a:t>Csoport módosítása</a:t>
             </a:r>
           </a:p>
           <a:p>
@@ -5587,7 +5587,7 @@
                 </a:solidFill>
                 <a:latin typeface="Segoe UI"/>
               </a:rPr>
-              <a:t>Csoport torlese (csak ha ures)</a:t>
+              <a:t>Csoport törlése (csak ha üres)</a:t>
             </a:r>
           </a:p>
           <a:p>
@@ -5599,7 +5599,7 @@
                 </a:solidFill>
                 <a:latin typeface="Segoe UI"/>
               </a:rPr>
-              <a:t>Egy csoport jelentkezoi</a:t>
+              <a:t>Egy csoport jelentkezői</a:t>
             </a:r>
           </a:p>
           <a:p>
@@ -5611,7 +5611,7 @@
                 </a:solidFill>
                 <a:latin typeface="Segoe UI"/>
               </a:rPr>
-              <a:t>Jelentkezo adatai</a:t>
+              <a:t>Jelentkező adatai</a:t>
             </a:r>
           </a:p>
           <a:p>
@@ -5623,7 +5623,7 @@
                 </a:solidFill>
                 <a:latin typeface="Segoe UI"/>
               </a:rPr>
-              <a:t>Jelentkezo modositasa</a:t>
+              <a:t>Jelentkező módosítása</a:t>
             </a:r>
           </a:p>
           <a:p>
@@ -5635,7 +5635,7 @@
                 </a:solidFill>
                 <a:latin typeface="Segoe UI"/>
               </a:rPr>
-              <a:t>Jelentkezo torlese</a:t>
+              <a:t>Jelentkező törlése</a:t>
             </a:r>
           </a:p>
         </p:txBody>
@@ -5696,7 +5696,7 @@
                 </a:solidFill>
                 <a:latin typeface="Segoe UI"/>
               </a:rPr>
-              <a:t>Tanfolyamok - Pogany Frigyes Technikum</a:t>
+              <a:t>Tanfolyamok - Pogány Frigyes Technikum</a:t>
             </a:r>
           </a:p>
         </p:txBody>
@@ -5766,7 +5766,7 @@
                 </a:solidFill>
                 <a:latin typeface="Segoe UI"/>
               </a:rPr>
-              <a:t>8. Hogyan vedett a rendszer?</a:t>
+              <a:t>8. Hogyan védett a rendszer?</a:t>
             </a:r>
           </a:p>
         </p:txBody>
@@ -5819,7 +5819,7 @@
                 </a:solidFill>
                 <a:latin typeface="Segoe UI"/>
               </a:rPr>
-              <a:t>Tanfolyamok - Pogany Frigyes Technikum</a:t>
+              <a:t>Tanfolyamok - Pogány Frigyes Technikum</a:t>
             </a:r>
           </a:p>
         </p:txBody>
@@ -5924,7 +5924,7 @@
                 </a:solidFill>
                 <a:latin typeface="Segoe UI"/>
               </a:rPr>
-              <a:t>1.  Mirol szol a projekt?</a:t>
+              <a:t>1.  Miről szól a projekt?</a:t>
             </a:r>
           </a:p>
           <a:p>
@@ -5936,7 +5936,7 @@
                 </a:solidFill>
                 <a:latin typeface="Segoe UI"/>
               </a:rPr>
-              <a:t>2.  Milyen eszkozokkel keszult?</a:t>
+              <a:t>2.  Milyen eszközökkel készült?</a:t>
             </a:r>
           </a:p>
           <a:p>
@@ -5948,7 +5948,7 @@
                 </a:solidFill>
                 <a:latin typeface="Segoe UI"/>
               </a:rPr>
-              <a:t>3.  Hogyan epul fel?</a:t>
+              <a:t>3.  Hogyan épül fel?</a:t>
             </a:r>
           </a:p>
           <a:p>
@@ -5960,7 +5960,7 @@
                 </a:solidFill>
                 <a:latin typeface="Segoe UI"/>
               </a:rPr>
-              <a:t>4.  Hogyan tarolja az adatokat?</a:t>
+              <a:t>4.  Hogyan tárolja az adatokat?</a:t>
             </a:r>
           </a:p>
           <a:p>
@@ -5972,7 +5972,7 @@
                 </a:solidFill>
                 <a:latin typeface="Segoe UI"/>
               </a:rPr>
-              <a:t>5.  Mit lat a latogato?</a:t>
+              <a:t>5.  Mit lát a látogató?</a:t>
             </a:r>
           </a:p>
           <a:p>
@@ -5984,7 +5984,7 @@
                 </a:solidFill>
                 <a:latin typeface="Segoe UI"/>
               </a:rPr>
-              <a:t>6.  Mit lat az admin?</a:t>
+              <a:t>6.  Mit lát az admin?</a:t>
             </a:r>
           </a:p>
         </p:txBody>
@@ -6019,7 +6019,7 @@
                 </a:solidFill>
                 <a:latin typeface="Segoe UI"/>
               </a:rPr>
-              <a:t>7.  Hogyan kommunikal a felulet a szerverrel?</a:t>
+              <a:t>7.  Hogyan kommunikál a felület a szerverrel?</a:t>
             </a:r>
           </a:p>
           <a:p>
@@ -6031,7 +6031,7 @@
                 </a:solidFill>
                 <a:latin typeface="Segoe UI"/>
               </a:rPr>
-              <a:t>8.  Hogyan vedett a rendszer?</a:t>
+              <a:t>8.  Hogyan védett a rendszer?</a:t>
             </a:r>
           </a:p>
           <a:p>
@@ -6043,7 +6043,7 @@
                 </a:solidFill>
                 <a:latin typeface="Segoe UI"/>
               </a:rPr>
-              <a:t>9.  Hogyan teszteltuk?</a:t>
+              <a:t>9.  Hogyan teszteltük?</a:t>
             </a:r>
           </a:p>
           <a:p>
@@ -6055,7 +6055,7 @@
                 </a:solidFill>
                 <a:latin typeface="Segoe UI"/>
               </a:rPr>
-              <a:t>10. Hogyan kell elinditani?</a:t>
+              <a:t>10. Hogyan kell elindítani?</a:t>
             </a:r>
           </a:p>
         </p:txBody>
@@ -6108,7 +6108,7 @@
                 </a:solidFill>
                 <a:latin typeface="Segoe UI"/>
               </a:rPr>
-              <a:t>Tanfolyamok - Pogany Frigyes Technikum</a:t>
+              <a:t>Tanfolyamok - Pogány Frigyes Technikum</a:t>
             </a:r>
           </a:p>
         </p:txBody>
@@ -6178,7 +6178,7 @@
                 </a:solidFill>
                 <a:latin typeface="Segoe UI"/>
               </a:rPr>
-              <a:t>Biztonsagi megoldasok</a:t>
+              <a:t>Biztonsági megoldások</a:t>
             </a:r>
           </a:p>
         </p:txBody>
@@ -6213,7 +6213,7 @@
                 </a:solidFill>
                 <a:latin typeface="Segoe UI"/>
               </a:rPr>
-              <a:t>Jelszo titkositas</a:t>
+              <a:t>Jelszó titkosítás</a:t>
             </a:r>
           </a:p>
           <a:p>
@@ -6225,7 +6225,7 @@
                 </a:solidFill>
                 <a:latin typeface="Segoe UI"/>
               </a:rPr>
-              <a:t>A jelszot nem sima szovegkent taroljuk, hanem titkositott formaban. Meg ha valaki lata a fajlt, nem tudja kiolvasni a jelszot belole.</a:t>
+              <a:t>A jelszót nem sima szövegként tároljuk, hanem titkosított formában. Még ha valaki látja a fájlt, nem tudja kiolvasni a jelszót belőle.</a:t>
             </a:r>
           </a:p>
           <a:p>
@@ -6249,7 +6249,7 @@
                 </a:solidFill>
                 <a:latin typeface="Segoe UI"/>
               </a:rPr>
-              <a:t>Belepesi igazolvany (token)</a:t>
+              <a:t>Belépési igazolvány (token)</a:t>
             </a:r>
           </a:p>
           <a:p>
@@ -6261,7 +6261,7 @@
                 </a:solidFill>
                 <a:latin typeface="Segoe UI"/>
               </a:rPr>
-              <a:t>Sikeres belepes utan a szerver kiad egy "igazolvanyt" ami 1 oraig ervenyes. Minden keresnel ezt mutatja be az admin. Ha lejar, ujra be kell lepni.</a:t>
+              <a:t>Sikeres belépés után a szerver kiad egy "igazolvanyt" ami 1 óráig érvényes. Minden kérésnél ezt mutatja be az admin. Ha lejár, újra be kell lépni.</a:t>
             </a:r>
           </a:p>
           <a:p>
@@ -6285,7 +6285,7 @@
                 </a:solidFill>
                 <a:latin typeface="Segoe UI"/>
               </a:rPr>
-              <a:t>Kulon titkos fajl (.env)</a:t>
+              <a:t>Külön titkos fájl (.env)</a:t>
             </a:r>
           </a:p>
           <a:p>
@@ -6297,7 +6297,7 @@
                 </a:solidFill>
                 <a:latin typeface="Segoe UI"/>
               </a:rPr>
-              <a:t>A jelszo es a titkos kulcs egy kulon fajlban vannak, nem a program kodjaban. Ez a fajl nem kerul fel az internetre.</a:t>
+              <a:t>A jelszó és a titkos kulcs egy külön fájlban vannak, nem a program kódjában. Ez a fájl nem kerül fel az internetre.</a:t>
             </a:r>
           </a:p>
           <a:p>
@@ -6333,7 +6333,7 @@
                 </a:solidFill>
                 <a:latin typeface="Segoe UI"/>
               </a:rPr>
-              <a:t>Egy e-maillel csak egyszer lehet jelentkezni egy csoportba. Egy csoportba max 8 fo fer. Csoportot csak uresen lehet torolni.</a:t>
+              <a:t>Egy e-maillel csak egyszer lehet jelentkezni egy csoportba. Egy csoportba max 8 fő fér. Csoportot csak üresen lehet törölni.</a:t>
             </a:r>
           </a:p>
           <a:p>
@@ -6406,7 +6406,7 @@
                 </a:solidFill>
                 <a:latin typeface="Segoe UI"/>
               </a:rPr>
-              <a:t>Tanfolyamok - Pogany Frigyes Technikum</a:t>
+              <a:t>Tanfolyamok - Pogány Frigyes Technikum</a:t>
             </a:r>
           </a:p>
         </p:txBody>
@@ -6476,7 +6476,7 @@
                 </a:solidFill>
                 <a:latin typeface="Segoe UI"/>
               </a:rPr>
-              <a:t>9. Hogyan teszteltuk?</a:t>
+              <a:t>9. Hogyan teszteltük?</a:t>
             </a:r>
           </a:p>
         </p:txBody>
@@ -6529,7 +6529,7 @@
                 </a:solidFill>
                 <a:latin typeface="Segoe UI"/>
               </a:rPr>
-              <a:t>Tanfolyamok - Pogany Frigyes Technikum</a:t>
+              <a:t>Tanfolyamok - Pogány Frigyes Technikum</a:t>
             </a:r>
           </a:p>
         </p:txBody>
@@ -6599,7 +6599,7 @@
                 </a:solidFill>
                 <a:latin typeface="Segoe UI"/>
               </a:rPr>
-              <a:t>Teszteles</a:t>
+              <a:t>Tesztelés</a:t>
             </a:r>
           </a:p>
         </p:txBody>
@@ -6634,7 +6634,7 @@
                 </a:solidFill>
                 <a:latin typeface="Segoe UI"/>
               </a:rPr>
-              <a:t>Szerver tesztek (.http fajlok)</a:t>
+              <a:t>Szerver tesztek (.http fájlok)</a:t>
             </a:r>
           </a:p>
           <a:p>
@@ -6658,7 +6658,7 @@
                 </a:solidFill>
                 <a:latin typeface="Segoe UI"/>
               </a:rPr>
-              <a:t>Kuldunk kerelmet a szervernek es</a:t>
+              <a:t>Küldünk kérelmet a szervernek és</a:t>
             </a:r>
           </a:p>
           <a:p>
@@ -6670,7 +6670,7 @@
                 </a:solidFill>
                 <a:latin typeface="Segoe UI"/>
               </a:rPr>
-              <a:t>megnezzuk, a vart valasz jon-e vissza.</a:t>
+              <a:t>megnézzük, a várt válasz jön-e vissza.</a:t>
             </a:r>
           </a:p>
           <a:p>
@@ -6694,7 +6694,7 @@
                 </a:solidFill>
                 <a:latin typeface="Segoe UI"/>
               </a:rPr>
-              <a:t>Peldaul:</a:t>
+              <a:t>Például:</a:t>
             </a:r>
           </a:p>
           <a:p>
@@ -6706,7 +6706,7 @@
                 </a:solidFill>
                 <a:latin typeface="Segoe UI"/>
               </a:rPr>
-              <a:t>- Sikeres es sikertelen jelentkezes</a:t>
+              <a:t>- Sikeres és sikertelen jelentkezés</a:t>
             </a:r>
           </a:p>
           <a:p>
@@ -6718,7 +6718,7 @@
                 </a:solidFill>
                 <a:latin typeface="Segoe UI"/>
               </a:rPr>
-              <a:t>- Csoport letrehozas, modositas, torles</a:t>
+              <a:t>- Csoport létrehozás, módosítás, törlés</a:t>
             </a:r>
           </a:p>
           <a:p>
@@ -6730,7 +6730,7 @@
                 </a:solidFill>
                 <a:latin typeface="Segoe UI"/>
               </a:rPr>
-              <a:t>- Hibas jelszo, lejart token</a:t>
+              <a:t>- Hibás jelszó, lejárt token</a:t>
             </a:r>
           </a:p>
           <a:p>
@@ -6742,7 +6742,7 @@
                 </a:solidFill>
                 <a:latin typeface="Segoe UI"/>
               </a:rPr>
-              <a:t>- Teli csoport, nem letezo csoport</a:t>
+              <a:t>- Teli csoport, nem létező csoport</a:t>
             </a:r>
           </a:p>
         </p:txBody>
@@ -6777,7 +6777,7 @@
                 </a:solidFill>
                 <a:latin typeface="Segoe UI"/>
               </a:rPr>
-              <a:t>Feluleti tesztek (kezzel)</a:t>
+              <a:t>Felületi tesztek (kézzel)</a:t>
             </a:r>
           </a:p>
           <a:p>
@@ -6801,7 +6801,7 @@
                 </a:solidFill>
                 <a:latin typeface="Segoe UI"/>
               </a:rPr>
-              <a:t>Bongeszobe betoltjuk az oldalt</a:t>
+              <a:t>Böngészőbe betöltjük az oldalt</a:t>
             </a:r>
           </a:p>
           <a:p>
@@ -6813,7 +6813,7 @@
                 </a:solidFill>
                 <a:latin typeface="Segoe UI"/>
               </a:rPr>
-              <a:t>es vegigcsinaljuk a muveleteket:</a:t>
+              <a:t>és végigcsináljuk a műveleteket:</a:t>
             </a:r>
           </a:p>
           <a:p>
@@ -6849,7 +6849,7 @@
                 </a:solidFill>
                 <a:latin typeface="Segoe UI"/>
               </a:rPr>
-              <a:t>24 nyilvanos teszteset</a:t>
+              <a:t>24 nyilvános teszteset</a:t>
             </a:r>
           </a:p>
           <a:p>
@@ -6873,7 +6873,7 @@
                 </a:solidFill>
                 <a:latin typeface="Segoe UI"/>
               </a:rPr>
-              <a:t>Eredmenyek: test_execution_log.xlsx</a:t>
+              <a:t>Eredmények: test_execution_log.xlsx</a:t>
             </a:r>
           </a:p>
           <a:p>
@@ -6885,7 +6885,7 @@
                 </a:solidFill>
                 <a:latin typeface="Segoe UI"/>
               </a:rPr>
-              <a:t>Tesztadatok: 3 kepzes, 5 csoport, 21 fo</a:t>
+              <a:t>Tesztadatok: 3 képzés, 5 csoport, 21 fő</a:t>
             </a:r>
           </a:p>
         </p:txBody>
@@ -6946,7 +6946,7 @@
                 </a:solidFill>
                 <a:latin typeface="Segoe UI"/>
               </a:rPr>
-              <a:t>Tanfolyamok - Pogany Frigyes Technikum</a:t>
+              <a:t>Tanfolyamok - Pogány Frigyes Technikum</a:t>
             </a:r>
           </a:p>
         </p:txBody>
@@ -7016,7 +7016,7 @@
                 </a:solidFill>
                 <a:latin typeface="Segoe UI"/>
               </a:rPr>
-              <a:t>10. Hogyan kell elinditani?</a:t>
+              <a:t>10. Hogyan kell elindítani?</a:t>
             </a:r>
           </a:p>
         </p:txBody>
@@ -7069,7 +7069,7 @@
                 </a:solidFill>
                 <a:latin typeface="Segoe UI"/>
               </a:rPr>
-              <a:t>Tanfolyamok - Pogany Frigyes Technikum</a:t>
+              <a:t>Tanfolyamok - Pogány Frigyes Technikum</a:t>
             </a:r>
           </a:p>
         </p:txBody>
@@ -7139,7 +7139,7 @@
                 </a:solidFill>
                 <a:latin typeface="Segoe UI"/>
               </a:rPr>
-              <a:t>Telepites es inditas</a:t>
+              <a:t>Telepítés és indítás</a:t>
             </a:r>
           </a:p>
         </p:txBody>
@@ -7174,7 +7174,7 @@
                 </a:solidFill>
                 <a:latin typeface="Segoe UI"/>
               </a:rPr>
-              <a:t>1. Csomagok telepitese</a:t>
+              <a:t>1. Csomagok telepítése</a:t>
             </a:r>
           </a:p>
           <a:p>
@@ -7198,7 +7198,7 @@
                 </a:solidFill>
                 <a:latin typeface="Segoe UI"/>
               </a:rPr>
-              <a:t>   Letolti az osszes szukseges kiegeszitot</a:t>
+              <a:t>   Letölti az összes szükséges kiegészítőt</a:t>
             </a:r>
           </a:p>
           <a:p>
@@ -7222,7 +7222,7 @@
                 </a:solidFill>
                 <a:latin typeface="Segoe UI"/>
               </a:rPr>
-              <a:t>2. Jelszo generalasa</a:t>
+              <a:t>2. Jelszó generálása</a:t>
             </a:r>
           </a:p>
           <a:p>
@@ -7246,7 +7246,7 @@
                 </a:solidFill>
                 <a:latin typeface="Segoe UI"/>
               </a:rPr>
-              <a:t>   Letrehozza a titkositott jelszot</a:t>
+              <a:t>   Létrehozza a titkosított jelszót</a:t>
             </a:r>
           </a:p>
           <a:p>
@@ -7270,7 +7270,7 @@
                 </a:solidFill>
                 <a:latin typeface="Segoe UI"/>
               </a:rPr>
-              <a:t>3. Titkos fajl letrehozasa</a:t>
+              <a:t>3. Titkos fájl létrehozása</a:t>
             </a:r>
           </a:p>
           <a:p>
@@ -7282,7 +7282,7 @@
                 </a:solidFill>
                 <a:latin typeface="Segoe UI"/>
               </a:rPr>
-              <a:t>   .env fajl a fo mappaban</a:t>
+              <a:t>   .env fájl a fő mappában</a:t>
             </a:r>
           </a:p>
           <a:p>
@@ -7294,7 +7294,7 @@
                 </a:solidFill>
                 <a:latin typeface="Segoe UI"/>
               </a:rPr>
-              <a:t>   Ide kerul a titkositott jelszo es a titkos kulcs</a:t>
+              <a:t>   Ide kerül a titkosított jelszó és a titkos kulcs</a:t>
             </a:r>
           </a:p>
           <a:p>
@@ -7318,7 +7318,7 @@
                 </a:solidFill>
                 <a:latin typeface="Segoe UI"/>
               </a:rPr>
-              <a:t>4. Inditas</a:t>
+              <a:t>4. Indítás</a:t>
             </a:r>
           </a:p>
           <a:p>
@@ -7366,7 +7366,7 @@
                 </a:solidFill>
                 <a:latin typeface="Segoe UI"/>
               </a:rPr>
-              <a:t>5. Megnyitas</a:t>
+              <a:t>5. Megnyitás</a:t>
             </a:r>
           </a:p>
           <a:p>
@@ -7390,7 +7390,7 @@
                 </a:solidFill>
                 <a:latin typeface="Segoe UI"/>
               </a:rPr>
-              <a:t>   A bongeszobe beirva megjelenik az oldal</a:t>
+              <a:t>   A böngészőbe beírva megjelenik az oldal</a:t>
             </a:r>
           </a:p>
           <a:p>
@@ -7463,7 +7463,7 @@
                 </a:solidFill>
                 <a:latin typeface="Segoe UI"/>
               </a:rPr>
-              <a:t>Osszefoglalas</a:t>
+              <a:t>Összefoglalás</a:t>
             </a:r>
           </a:p>
         </p:txBody>
@@ -7498,7 +7498,7 @@
                 </a:solidFill>
                 <a:latin typeface="Segoe UI"/>
               </a:rPr>
-              <a:t>  Teljes koru weboldal tanfolyamok kezelesere</a:t>
+              <a:t>  Teljes körű weboldal tanfolyamok kezelésére</a:t>
             </a:r>
           </a:p>
           <a:p>
@@ -7510,7 +7510,7 @@
                 </a:solidFill>
                 <a:latin typeface="Segoe UI"/>
               </a:rPr>
-              <a:t>  3 reszes felepites: weboldal + szerver + adatbazis</a:t>
+              <a:t>  3 részes felépítés: weboldal + szerver + adatbázis</a:t>
             </a:r>
           </a:p>
           <a:p>
@@ -7522,7 +7522,7 @@
                 </a:solidFill>
                 <a:latin typeface="Segoe UI"/>
               </a:rPr>
-              <a:t>  12 szerver vegpont (2 nyilvanos + 10 jelszovedett)</a:t>
+              <a:t>  12 szerver végpont (2 nyilvános + 10 jelszóvédett)</a:t>
             </a:r>
           </a:p>
           <a:p>
@@ -7534,7 +7534,7 @@
                 </a:solidFill>
                 <a:latin typeface="Segoe UI"/>
               </a:rPr>
-              <a:t>  Biztonsagos: titkositott jelszo + belepesi igazolvany</a:t>
+              <a:t>  Biztonságos: titkosított jelszó + belépési igazolvány</a:t>
             </a:r>
           </a:p>
           <a:p>
@@ -7546,7 +7546,7 @@
                 </a:solidFill>
                 <a:latin typeface="Segoe UI"/>
               </a:rPr>
-              <a:t>  Ellenorzesek mindket oldalon (bongeszoben es szerveren is)</a:t>
+              <a:t>  Ellenőrzések mindkét oldalon (böngészőben és szerveren is)</a:t>
             </a:r>
           </a:p>
           <a:p>
@@ -7558,7 +7558,7 @@
                 </a:solidFill>
                 <a:latin typeface="Segoe UI"/>
               </a:rPr>
-              <a:t>  51 teszteset: feluleti es szerver tesztek</a:t>
+              <a:t>  51 teszteset: felületi és szerver tesztek</a:t>
             </a:r>
           </a:p>
           <a:p>
@@ -7570,7 +7570,7 @@
                 </a:solidFill>
                 <a:latin typeface="Segoe UI"/>
               </a:rPr>
-              <a:t>  Telefonon is jol mukodo design</a:t>
+              <a:t>  Telefonon is jól működő design</a:t>
             </a:r>
           </a:p>
         </p:txBody>
@@ -7605,7 +7605,7 @@
                 </a:solidFill>
                 <a:latin typeface="Segoe UI"/>
               </a:rPr>
-              <a:t>Koszonjuk a figyelmet!</a:t>
+              <a:t>Köszönjük a figyelmet!</a:t>
             </a:r>
           </a:p>
         </p:txBody>
@@ -7640,7 +7640,7 @@
                 </a:solidFill>
                 <a:latin typeface="Segoe UI"/>
               </a:rPr>
-              <a:t>Andorfer Vendel  |  Babai Mate  |  Varga Matyas</a:t>
+              <a:t>Andorfer Vendel  |  Babai Máté  |  Varga Mátyás</a:t>
             </a:r>
           </a:p>
         </p:txBody>
@@ -7701,7 +7701,7 @@
                 </a:solidFill>
                 <a:latin typeface="Segoe UI"/>
               </a:rPr>
-              <a:t>Tanfolyamok - Pogany Frigyes Technikum</a:t>
+              <a:t>Tanfolyamok - Pogány Frigyes Technikum</a:t>
             </a:r>
           </a:p>
         </p:txBody>
@@ -7771,7 +7771,7 @@
                 </a:solidFill>
                 <a:latin typeface="Segoe UI"/>
               </a:rPr>
-              <a:t>1. Mirol szol a projekt?</a:t>
+              <a:t>1. Miről szól a projekt?</a:t>
             </a:r>
           </a:p>
         </p:txBody>
@@ -7806,7 +7806,7 @@
                 </a:solidFill>
                 <a:latin typeface="Segoe UI"/>
               </a:rPr>
-              <a:t>Miert es kinek keszult ez az alkalmazas?</a:t>
+              <a:t>Miért és kinek készült ez az alkalmazás?</a:t>
             </a:r>
           </a:p>
         </p:txBody>
@@ -7859,7 +7859,7 @@
                 </a:solidFill>
                 <a:latin typeface="Segoe UI"/>
               </a:rPr>
-              <a:t>Tanfolyamok - Pogany Frigyes Technikum</a:t>
+              <a:t>Tanfolyamok - Pogány Frigyes Technikum</a:t>
             </a:r>
           </a:p>
         </p:txBody>
@@ -7929,7 +7929,7 @@
                 </a:solidFill>
                 <a:latin typeface="Segoe UI"/>
               </a:rPr>
-              <a:t>A projekt hattere</a:t>
+              <a:t>A projekt háttere</a:t>
             </a:r>
           </a:p>
         </p:txBody>
@@ -7964,7 +7964,7 @@
                 </a:solidFill>
                 <a:latin typeface="Segoe UI"/>
               </a:rPr>
-              <a:t>Iskola: BKSZC Pogany Frigyes Technikum (Budapest)</a:t>
+              <a:t>Iskola: BKSZC Pogány Frigyes Technikum (Budapest)</a:t>
             </a:r>
           </a:p>
           <a:p>
@@ -7988,7 +7988,7 @@
                 </a:solidFill>
                 <a:latin typeface="Segoe UI"/>
               </a:rPr>
-              <a:t>Az iskola esti es hetvegi digitalis kepzeseket kinal felnotteknek.</a:t>
+              <a:t>Az iskola esti és hétvégi digitális képzéseket kínál felnőtteknek.</a:t>
             </a:r>
           </a:p>
           <a:p>
@@ -8000,7 +8000,7 @@
                 </a:solidFill>
                 <a:latin typeface="Segoe UI"/>
               </a:rPr>
-              <a:t>A jelentkezesek korabban papir alapon tortentek.</a:t>
+              <a:t>A jelentkezések korábban papír alapon történtek.</a:t>
             </a:r>
           </a:p>
           <a:p>
@@ -8024,7 +8024,7 @@
                 </a:solidFill>
                 <a:latin typeface="Segoe UI"/>
               </a:rPr>
-              <a:t>A cel: egy weboldal ahol az erdeklodok megtalaljak a tanfolyamokat</a:t>
+              <a:t>A cél: egy weboldal ahol az érdeklődők megtalálják a tanfolyamokat</a:t>
             </a:r>
           </a:p>
           <a:p>
@@ -8036,7 +8036,7 @@
                 </a:solidFill>
                 <a:latin typeface="Segoe UI"/>
               </a:rPr>
-              <a:t>es online tudnak jelentkezni - az adminisztrator pedig tudja kezelni</a:t>
+              <a:t>és online tudnak jelentkezni - az adminisztrátor pedig tudja kezelni</a:t>
             </a:r>
           </a:p>
           <a:p>
@@ -8048,7 +8048,7 @@
                 </a:solidFill>
                 <a:latin typeface="Segoe UI"/>
               </a:rPr>
-              <a:t>a csoportokat es a jelentkezok adatait.</a:t>
+              <a:t>a csoportokat és a jelentkezők adatait.</a:t>
             </a:r>
           </a:p>
           <a:p>
@@ -8072,7 +8072,7 @@
                 </a:solidFill>
                 <a:latin typeface="Segoe UI"/>
               </a:rPr>
-              <a:t>3 fos csapat, iskolai projektmunka, 2026-os tanev</a:t>
+              <a:t>3 fős csapat, iskolai projektmunka, 2026-os tanév</a:t>
             </a:r>
           </a:p>
         </p:txBody>
@@ -8125,7 +8125,7 @@
                 </a:solidFill>
                 <a:latin typeface="Segoe UI"/>
               </a:rPr>
-              <a:t>Tanfolyamok - Pogany Frigyes Technikum</a:t>
+              <a:t>Tanfolyamok - Pogány Frigyes Technikum</a:t>
             </a:r>
           </a:p>
         </p:txBody>
@@ -8195,7 +8195,7 @@
                 </a:solidFill>
                 <a:latin typeface="Segoe UI"/>
               </a:rPr>
-              <a:t>A harom elerheto kepzes</a:t>
+              <a:t>A három elérhető képzés</a:t>
             </a:r>
           </a:p>
         </p:txBody>
@@ -8230,7 +8230,7 @@
                 </a:solidFill>
                 <a:latin typeface="Segoe UI"/>
               </a:rPr>
-              <a:t>Teljesen nullarol</a:t>
+              <a:t>Teljesen nulláról</a:t>
             </a:r>
           </a:p>
           <a:p>
@@ -8242,7 +8242,7 @@
                 </a:solidFill>
                 <a:latin typeface="Segoe UI"/>
               </a:rPr>
-              <a:t>40 ora</a:t>
+              <a:t>40 óra</a:t>
             </a:r>
           </a:p>
           <a:p>
@@ -8266,7 +8266,7 @@
                 </a:solidFill>
                 <a:latin typeface="Segoe UI"/>
               </a:rPr>
-              <a:t>Alapok: szamitogep, internet, e-mail, jelszavak</a:t>
+              <a:t>Alapok: számítógép, internet, e-mail, jelszavak</a:t>
             </a:r>
           </a:p>
         </p:txBody>
@@ -8301,7 +8301,7 @@
                 </a:solidFill>
                 <a:latin typeface="Segoe UI"/>
               </a:rPr>
-              <a:t>Mindennapi internethasznalat</a:t>
+              <a:t>Mindennapi internethasználat</a:t>
             </a:r>
           </a:p>
           <a:p>
@@ -8313,7 +8313,7 @@
                 </a:solidFill>
                 <a:latin typeface="Segoe UI"/>
               </a:rPr>
-              <a:t>40 ora</a:t>
+              <a:t>40 óra</a:t>
             </a:r>
           </a:p>
           <a:p>
@@ -8337,7 +8337,7 @@
                 </a:solidFill>
                 <a:latin typeface="Segoe UI"/>
               </a:rPr>
-              <a:t>Telefon es laptop egyutt, fajlok, alkalmazasok</a:t>
+              <a:t>Telefon és laptop együtt, fájlok, alkalmazások</a:t>
             </a:r>
           </a:p>
         </p:txBody>
@@ -8372,7 +8372,7 @@
                 </a:solidFill>
                 <a:latin typeface="Segoe UI"/>
               </a:rPr>
-              <a:t>Tudatos es biztonsagos internet</a:t>
+              <a:t>Tudatos és biztonságos internet</a:t>
             </a:r>
           </a:p>
           <a:p>
@@ -8384,7 +8384,7 @@
                 </a:solidFill>
                 <a:latin typeface="Segoe UI"/>
               </a:rPr>
-              <a:t>80 ora</a:t>
+              <a:t>80 óra</a:t>
             </a:r>
           </a:p>
           <a:p>
@@ -8408,7 +8408,7 @@
                 </a:solidFill>
                 <a:latin typeface="Segoe UI"/>
               </a:rPr>
-              <a:t>Atveresek, adatvedelem, ketlepeses azonositas</a:t>
+              <a:t>Átverések, adatvédelem, kétlépéses azonosítás</a:t>
             </a:r>
           </a:p>
         </p:txBody>
@@ -8443,7 +8443,7 @@
                 </a:solidFill>
                 <a:latin typeface="Segoe UI"/>
               </a:rPr>
-              <a:t>Mindharom kepzesbol tobb csoport is indulhat, kulonbozo idopontokban es helyszineken.</a:t>
+              <a:t>Mindhárom képzésből több csoport is indulhat, különböző időpontokban és helyszíneken.</a:t>
             </a:r>
           </a:p>
         </p:txBody>
@@ -8504,7 +8504,7 @@
                 </a:solidFill>
                 <a:latin typeface="Segoe UI"/>
               </a:rPr>
-              <a:t>Tanfolyamok - Pogany Frigyes Technikum</a:t>
+              <a:t>Tanfolyamok - Pogány Frigyes Technikum</a:t>
             </a:r>
           </a:p>
         </p:txBody>
@@ -8574,7 +8574,7 @@
                 </a:solidFill>
                 <a:latin typeface="Segoe UI"/>
               </a:rPr>
-              <a:t>2. Milyen eszkozokkel keszult?</a:t>
+              <a:t>2. Milyen eszközökkel készült?</a:t>
             </a:r>
           </a:p>
         </p:txBody>
@@ -8627,7 +8627,7 @@
                 </a:solidFill>
                 <a:latin typeface="Segoe UI"/>
               </a:rPr>
-              <a:t>Tanfolyamok - Pogany Frigyes Technikum</a:t>
+              <a:t>Tanfolyamok - Pogány Frigyes Technikum</a:t>
             </a:r>
           </a:p>
         </p:txBody>
@@ -8697,7 +8697,7 @@
                 </a:solidFill>
                 <a:latin typeface="Segoe UI"/>
               </a:rPr>
-              <a:t>Hasznalt eszkozok</a:t>
+              <a:t>Használt eszközök</a:t>
             </a:r>
           </a:p>
         </p:txBody>
@@ -8732,7 +8732,7 @@
                 </a:solidFill>
                 <a:latin typeface="Segoe UI"/>
               </a:rPr>
-              <a:t>Szerver oldal (a hatterben dolgozik)</a:t>
+              <a:t>Szerver oldal (a háttérben dolgozik)</a:t>
             </a:r>
           </a:p>
           <a:p>
@@ -8756,7 +8756,7 @@
                 </a:solidFill>
                 <a:latin typeface="Segoe UI"/>
               </a:rPr>
-              <a:t>Node.js - Futtatja a szerver kodot</a:t>
+              <a:t>Node.js - Futtatja a szerver kódot</a:t>
             </a:r>
           </a:p>
           <a:p>
@@ -8768,7 +8768,7 @@
                 </a:solidFill>
                 <a:latin typeface="Segoe UI"/>
               </a:rPr>
-              <a:t>Express.js - Fogadja a kereseket, kuldi a valaszokat</a:t>
+              <a:t>Express.js - Fogadja a kéréseket, küldi a válaszokat</a:t>
             </a:r>
           </a:p>
           <a:p>
@@ -8780,7 +8780,7 @@
                 </a:solidFill>
                 <a:latin typeface="Segoe UI"/>
               </a:rPr>
-              <a:t>SQLite - Tarolja az adatokat (1 fajl)</a:t>
+              <a:t>SQLite - Tárolja az adatokat (1 fájl)</a:t>
             </a:r>
           </a:p>
           <a:p>
@@ -8792,7 +8792,7 @@
                 </a:solidFill>
                 <a:latin typeface="Segoe UI"/>
               </a:rPr>
-              <a:t>bcrypt - Jelszot titkosit</a:t>
+              <a:t>bcrypt - Jelszót titkosít</a:t>
             </a:r>
           </a:p>
           <a:p>
@@ -8804,7 +8804,7 @@
                 </a:solidFill>
                 <a:latin typeface="Segoe UI"/>
               </a:rPr>
-              <a:t>JWT - Belepes igazolvany (token)</a:t>
+              <a:t>JWT - Belépés igazolvány (token)</a:t>
             </a:r>
           </a:p>
           <a:p>
@@ -8816,7 +8816,7 @@
                 </a:solidFill>
                 <a:latin typeface="Segoe UI"/>
               </a:rPr>
-              <a:t>dotenv - Titkos adatok kulon fajlban</a:t>
+              <a:t>dotenv - Titkos adatok külön fájlban</a:t>
             </a:r>
           </a:p>
         </p:txBody>
@@ -8851,7 +8851,7 @@
                 </a:solidFill>
                 <a:latin typeface="Segoe UI"/>
               </a:rPr>
-              <a:t>Felulet (amit a felhasznalo lat)</a:t>
+              <a:t>Felület (amit a felhasználó lát)</a:t>
             </a:r>
           </a:p>
           <a:p>
@@ -8887,7 +8887,7 @@
                 </a:solidFill>
                 <a:latin typeface="Segoe UI"/>
               </a:rPr>
-              <a:t>CSS - Az oldal kinezete, szinek</a:t>
+              <a:t>CSS - Az oldal kinézete, színek</a:t>
             </a:r>
           </a:p>
           <a:p>
@@ -8899,7 +8899,7 @@
                 </a:solidFill>
                 <a:latin typeface="Segoe UI"/>
               </a:rPr>
-              <a:t>JavaScript - Az oldal mukodese, gombok</a:t>
+              <a:t>JavaScript - Az oldal működése, gombok</a:t>
             </a:r>
           </a:p>
           <a:p>
@@ -8911,7 +8911,7 @@
                 </a:solidFill>
                 <a:latin typeface="Segoe UI"/>
               </a:rPr>
-              <a:t>Bootstrap 5 - Reszponziv design (telefonon is jo)</a:t>
+              <a:t>Bootstrap 5 - Reszponzív design (telefonon is jó)</a:t>
             </a:r>
           </a:p>
           <a:p>
@@ -8923,7 +8923,7 @@
                 </a:solidFill>
                 <a:latin typeface="Segoe UI"/>
               </a:rPr>
-              <a:t>Fetch API - Adatok lekerese a szerverrol</a:t>
+              <a:t>Fetch API - Adatok lekérése a szerverről</a:t>
             </a:r>
           </a:p>
         </p:txBody>
@@ -8984,7 +8984,7 @@
                 </a:solidFill>
                 <a:latin typeface="Segoe UI"/>
               </a:rPr>
-              <a:t>Tanfolyamok - Pogany Frigyes Technikum</a:t>
+              <a:t>Tanfolyamok - Pogány Frigyes Technikum</a:t>
             </a:r>
           </a:p>
         </p:txBody>
@@ -9054,7 +9054,7 @@
                 </a:solidFill>
                 <a:latin typeface="Segoe UI"/>
               </a:rPr>
-              <a:t>3. Hogyan epul fel?</a:t>
+              <a:t>3. Hogyan épül fel?</a:t>
             </a:r>
           </a:p>
         </p:txBody>
@@ -9107,7 +9107,7 @@
                 </a:solidFill>
                 <a:latin typeface="Segoe UI"/>
               </a:rPr>
-              <a:t>Tanfolyamok - Pogany Frigyes Technikum</a:t>
+              <a:t>Tanfolyamok - Pogány Frigyes Technikum</a:t>
             </a:r>
           </a:p>
         </p:txBody>
@@ -9177,7 +9177,7 @@
                 </a:solidFill>
                 <a:latin typeface="Segoe UI"/>
               </a:rPr>
-              <a:t>Az alkalmazas 3 reszbol all</a:t>
+              <a:t>Az alkalmazás 3 részből áll</a:t>
             </a:r>
           </a:p>
         </p:txBody>
@@ -9212,7 +9212,7 @@
                 </a:solidFill>
                 <a:latin typeface="Segoe UI"/>
               </a:rPr>
-              <a:t>Weboldal (bongeszo)</a:t>
+              <a:t>Weboldal (böngésző)</a:t>
             </a:r>
           </a:p>
           <a:p>
@@ -9248,7 +9248,7 @@
                 </a:solidFill>
                 <a:latin typeface="Segoe UI"/>
               </a:rPr>
-              <a:t>Ezt latja a felhasznalo</a:t>
+              <a:t>Ezt látja a felhasználó</a:t>
             </a:r>
           </a:p>
           <a:p>
@@ -9260,7 +9260,7 @@
                 </a:solidFill>
                 <a:latin typeface="Segoe UI"/>
               </a:rPr>
-              <a:t>Bongeszobe toltodik</a:t>
+              <a:t>Böngészőbe töltődik</a:t>
             </a:r>
           </a:p>
         </p:txBody>
@@ -9331,7 +9331,7 @@
                 </a:solidFill>
                 <a:latin typeface="Segoe UI"/>
               </a:rPr>
-              <a:t>Kerelmeket fogad</a:t>
+              <a:t>Kérelmeket fogad</a:t>
             </a:r>
           </a:p>
           <a:p>
@@ -9343,7 +9343,7 @@
                 </a:solidFill>
                 <a:latin typeface="Segoe UI"/>
               </a:rPr>
-              <a:t>Valaszokat kuld</a:t>
+              <a:t>Válaszokat küld</a:t>
             </a:r>
           </a:p>
         </p:txBody>
@@ -9378,7 +9378,7 @@
                 </a:solidFill>
                 <a:latin typeface="Segoe UI"/>
               </a:rPr>
-              <a:t>Adatbazis (SQLite)</a:t>
+              <a:t>Adatbázis (SQLite)</a:t>
             </a:r>
           </a:p>
           <a:p>
@@ -9402,7 +9402,7 @@
                 </a:solidFill>
                 <a:latin typeface="Segoe UI"/>
               </a:rPr>
-              <a:t>tanfolyamok.db fajl</a:t>
+              <a:t>tanfolyamok.db fájl</a:t>
             </a:r>
           </a:p>
           <a:p>
@@ -9414,7 +9414,7 @@
                 </a:solidFill>
                 <a:latin typeface="Segoe UI"/>
               </a:rPr>
-              <a:t>3 tabla</a:t>
+              <a:t>3 tábla</a:t>
             </a:r>
           </a:p>
           <a:p>
@@ -9531,7 +9531,7 @@
                 </a:solidFill>
                 <a:latin typeface="Segoe UI"/>
               </a:rPr>
-              <a:t>A felhasznalo a bongeszojeben nyitja meg az oldalt. Amikor barmit csinal (jelentkezik, adatot ker), a bongeszo egy kerelmet kuld a szervernek. A szerver feldolgozza a kerelmet, szukseges eseten adatot olvas vagy ir az adatbazisba, es visszakuldi a valaszt a bongeszobe.</a:t>
+              <a:t>A felhasználó a böngészőjében nyitja meg az oldalt. Amikor bármit csinál (jelentkezik, adatot kér), a böngésző egy kérelmet küld a szervernek. A szerver feldolgozza a kérelmet, szükséges esetén adatot olvas vagy ír az adatbázisba, és visszaküldi a választ a böngészőbe.</a:t>
             </a:r>
           </a:p>
         </p:txBody>

</xml_diff>